<commit_message>
prepare portfolio forecasting app + bugfixes + .md
</commit_message>
<xml_diff>
--- a/notes/demo.pptx
+++ b/notes/demo.pptx
@@ -12,6 +12,7 @@
     <p:sldId id="260" r:id="rId6"/>
     <p:sldId id="261" r:id="rId7"/>
     <p:sldId id="262" r:id="rId8"/>
+    <p:sldId id="265" r:id="rId16"/>
     <p:sldId id="263" r:id="rId9"/>
     <p:sldId id="264" r:id="rId10"/>
   </p:sldIdLst>
@@ -1783,6 +1784,980 @@
 </p:sld>
 </file>
 
+<file path=ppt/slides/slide10.xml><?xml version="1.0" encoding="utf-8"?>
+<p:sld xmlns:a="http://schemas.openxmlformats.org/drawingml/2006/main" xmlns:r="http://schemas.openxmlformats.org/officeDocument/2006/relationships" xmlns:p="http://schemas.openxmlformats.org/presentationml/2006/main">
+  <p:cSld name="Slide 7">
+    <p:bg>
+      <p:bgPr>
+        <a:solidFill>
+          <a:srgbClr val="FFFFFF"/>
+        </a:solidFill>
+      </p:bgPr>
+    </p:bg>
+    <p:spTree>
+      <p:nvGrpSpPr>
+        <p:cNvPr id="1" name=""/>
+        <p:cNvGrpSpPr/>
+        <p:nvPr/>
+      </p:nvGrpSpPr>
+      <p:grpSpPr>
+        <a:xfrm>
+          <a:off x="0" y="0"/>
+          <a:ext cx="0" cy="0"/>
+          <a:chOff x="0" y="0"/>
+          <a:chExt cx="0" cy="0"/>
+        </a:xfrm>
+      </p:grpSpPr>
+      <p:sp>
+        <p:nvSpPr>
+          <p:cNvPr id="2" name="Text 0"/>
+          <p:cNvSpPr txBox="1"/>
+          <p:nvPr/>
+        </p:nvSpPr>
+        <p:spPr>
+          <a:xfrm>
+            <a:off x="548640" y="457200"/>
+            <a:ext cx="7315200" cy="640080"/>
+          </a:xfrm>
+          <a:prstGeom prst="rect">
+            <a:avLst/>
+          </a:prstGeom>
+          <a:noFill/>
+          <a:ln/>
+        </p:spPr>
+        <p:txBody>
+          <a:bodyPr wrap="square" rtlCol="0" anchor="ctr"/>
+          <a:lstStyle/>
+          <a:p>
+            <a:pPr indent="0" marL="0">
+              <a:buNone/>
+            </a:pPr>
+            <a:r>
+              <a:rPr lang="en-US" sz="3200" b="1" dirty="0">
+                <a:solidFill>
+                  <a:srgbClr val="1E2761"/>
+                </a:solidFill>
+                <a:latin typeface="Cambria" pitchFamily="34" charset="0"/>
+                <a:ea typeface="Cambria" pitchFamily="34" charset="-122"/>
+                <a:cs typeface="Cambria" pitchFamily="34" charset="-120"/>
+              </a:rPr>
+              <a:t>AI layer &amp; fail-soft by design</a:t>
+            </a:r>
+            <a:endParaRPr lang="en-US" sz="3200" dirty="0"/>
+          </a:p>
+        </p:txBody>
+      </p:sp>
+      <p:sp>
+        <p:nvSpPr>
+          <p:cNvPr id="3" name="Shape 1"/>
+          <p:cNvSpPr/>
+          <p:nvPr/>
+        </p:nvSpPr>
+        <p:spPr>
+          <a:xfrm>
+            <a:off x="548640" y="1490472"/>
+            <a:ext cx="384048" cy="384048"/>
+          </a:xfrm>
+          <a:prstGeom prst="ellipse">
+            <a:avLst/>
+          </a:prstGeom>
+          <a:solidFill>
+            <a:srgbClr val="E7EEFB"/>
+          </a:solidFill>
+          <a:ln/>
+        </p:spPr>
+        <p:txBody>
+          <a:bodyPr/>
+          <a:p/>
+        </p:txBody>
+      </p:sp>
+      <p:sp>
+        <p:nvSpPr>
+          <p:cNvPr id="4" name="Text 2"/>
+          <p:cNvSpPr txBox="1"/>
+          <p:nvPr/>
+        </p:nvSpPr>
+        <p:spPr>
+          <a:xfrm>
+            <a:off x="548640" y="1490472"/>
+            <a:ext cx="384048" cy="384048"/>
+          </a:xfrm>
+          <a:prstGeom prst="rect">
+            <a:avLst/>
+          </a:prstGeom>
+          <a:noFill/>
+          <a:ln/>
+        </p:spPr>
+        <p:txBody>
+          <a:bodyPr wrap="square" rtlCol="0" anchor="ctr"/>
+          <a:lstStyle/>
+          <a:p>
+            <a:pPr algn="ctr" indent="0" marL="0">
+              <a:buNone/>
+            </a:pPr>
+            <a:r>
+              <a:rPr lang="en-US" sz="1600" b="1" dirty="0">
+                <a:solidFill>
+                  <a:srgbClr val="1E2761"/>
+                </a:solidFill>
+                <a:latin typeface="Cambria" pitchFamily="34" charset="0"/>
+                <a:ea typeface="Cambria" pitchFamily="34" charset="-122"/>
+                <a:cs typeface="Cambria" pitchFamily="34" charset="-120"/>
+              </a:rPr>
+              <a:t>✓</a:t>
+            </a:r>
+            <a:endParaRPr lang="en-US" sz="1600" dirty="0"/>
+          </a:p>
+        </p:txBody>
+      </p:sp>
+      <p:sp>
+        <p:nvSpPr>
+          <p:cNvPr id="5" name="Text 3"/>
+          <p:cNvSpPr txBox="1"/>
+          <p:nvPr/>
+        </p:nvSpPr>
+        <p:spPr>
+          <a:xfrm>
+            <a:off x="1097280" y="1399032"/>
+            <a:ext cx="4526280" cy="320040"/>
+          </a:xfrm>
+          <a:prstGeom prst="rect">
+            <a:avLst/>
+          </a:prstGeom>
+          <a:noFill/>
+          <a:ln/>
+        </p:spPr>
+        <p:txBody>
+          <a:bodyPr wrap="square" rtlCol="0" anchor="ctr"/>
+          <a:lstStyle/>
+          <a:p>
+            <a:pPr indent="0" marL="0">
+              <a:buNone/>
+            </a:pPr>
+            <a:r>
+              <a:rPr lang="en-US" sz="1450" b="1" dirty="0">
+                <a:solidFill>
+                  <a:srgbClr val="1A1A2E"/>
+                </a:solidFill>
+                <a:latin typeface="Cambria" pitchFamily="34" charset="0"/>
+                <a:ea typeface="Cambria" pitchFamily="34" charset="-122"/>
+                <a:cs typeface="Cambria" pitchFamily="34" charset="-120"/>
+              </a:rPr>
+              <a:t>3-tier sentiment cascade</a:t>
+            </a:r>
+            <a:endParaRPr lang="en-US" sz="1450" dirty="0"/>
+          </a:p>
+        </p:txBody>
+      </p:sp>
+      <p:sp>
+        <p:nvSpPr>
+          <p:cNvPr id="6" name="Text 4"/>
+          <p:cNvSpPr txBox="1"/>
+          <p:nvPr/>
+        </p:nvSpPr>
+        <p:spPr>
+          <a:xfrm>
+            <a:off x="1097280" y="1709928"/>
+            <a:ext cx="4526280" cy="594360"/>
+          </a:xfrm>
+          <a:prstGeom prst="rect">
+            <a:avLst/>
+          </a:prstGeom>
+          <a:noFill/>
+          <a:ln/>
+        </p:spPr>
+        <p:txBody>
+          <a:bodyPr wrap="square" rtlCol="0" anchor="ctr"/>
+          <a:lstStyle/>
+          <a:p>
+            <a:pPr indent="0" marL="0">
+              <a:lnSpc>
+                <a:spcPts val="1400"/>
+              </a:lnSpc>
+              <a:buNone/>
+            </a:pPr>
+            <a:r>
+              <a:rPr lang="en-US" sz="1150" dirty="0">
+                <a:solidFill>
+                  <a:srgbClr val="6B7280"/>
+                </a:solidFill>
+                <a:latin typeface="Calibri" pitchFamily="34" charset="0"/>
+                <a:ea typeface="Calibri" pitchFamily="34" charset="-122"/>
+                <a:cs typeface="Calibri" pitchFamily="34" charset="-120"/>
+              </a:rPr>
+              <a:t>FinBERT (financial-domain BERT) → Finnhub aggregated → VADER, always a real answer</a:t>
+            </a:r>
+            <a:endParaRPr lang="en-US" sz="1150" dirty="0"/>
+          </a:p>
+        </p:txBody>
+      </p:sp>
+      <p:sp>
+        <p:nvSpPr>
+          <p:cNvPr id="7" name="Shape 5"/>
+          <p:cNvSpPr/>
+          <p:nvPr/>
+        </p:nvSpPr>
+        <p:spPr>
+          <a:xfrm>
+            <a:off x="5897880" y="1490472"/>
+            <a:ext cx="384048" cy="384048"/>
+          </a:xfrm>
+          <a:prstGeom prst="ellipse">
+            <a:avLst/>
+          </a:prstGeom>
+          <a:solidFill>
+            <a:srgbClr val="E7EEFB"/>
+          </a:solidFill>
+          <a:ln/>
+        </p:spPr>
+        <p:txBody>
+          <a:bodyPr/>
+          <a:p/>
+        </p:txBody>
+      </p:sp>
+      <p:sp>
+        <p:nvSpPr>
+          <p:cNvPr id="8" name="Text 6"/>
+          <p:cNvSpPr txBox="1"/>
+          <p:nvPr/>
+        </p:nvSpPr>
+        <p:spPr>
+          <a:xfrm>
+            <a:off x="5897880" y="1490472"/>
+            <a:ext cx="384048" cy="384048"/>
+          </a:xfrm>
+          <a:prstGeom prst="rect">
+            <a:avLst/>
+          </a:prstGeom>
+          <a:noFill/>
+          <a:ln/>
+        </p:spPr>
+        <p:txBody>
+          <a:bodyPr wrap="square" rtlCol="0" anchor="ctr"/>
+          <a:lstStyle/>
+          <a:p>
+            <a:pPr algn="ctr" indent="0" marL="0">
+              <a:buNone/>
+            </a:pPr>
+            <a:r>
+              <a:rPr lang="en-US" sz="1600" b="1" dirty="0">
+                <a:solidFill>
+                  <a:srgbClr val="1E2761"/>
+                </a:solidFill>
+                <a:latin typeface="Cambria" pitchFamily="34" charset="0"/>
+                <a:ea typeface="Cambria" pitchFamily="34" charset="-122"/>
+                <a:cs typeface="Cambria" pitchFamily="34" charset="-120"/>
+              </a:rPr>
+              <a:t>✓</a:t>
+            </a:r>
+            <a:endParaRPr lang="en-US" sz="1600" dirty="0"/>
+          </a:p>
+        </p:txBody>
+      </p:sp>
+      <p:sp>
+        <p:nvSpPr>
+          <p:cNvPr id="9" name="Text 7"/>
+          <p:cNvSpPr txBox="1"/>
+          <p:nvPr/>
+        </p:nvSpPr>
+        <p:spPr>
+          <a:xfrm>
+            <a:off x="6446520" y="1399032"/>
+            <a:ext cx="4526280" cy="320040"/>
+          </a:xfrm>
+          <a:prstGeom prst="rect">
+            <a:avLst/>
+          </a:prstGeom>
+          <a:noFill/>
+          <a:ln/>
+        </p:spPr>
+        <p:txBody>
+          <a:bodyPr wrap="square" rtlCol="0" anchor="ctr"/>
+          <a:lstStyle/>
+          <a:p>
+            <a:pPr indent="0" marL="0">
+              <a:buNone/>
+            </a:pPr>
+            <a:r>
+              <a:rPr lang="en-US" sz="1450" b="1" dirty="0">
+                <a:solidFill>
+                  <a:srgbClr val="1A1A2E"/>
+                </a:solidFill>
+                <a:latin typeface="Cambria" pitchFamily="34" charset="0"/>
+                <a:ea typeface="Cambria" pitchFamily="34" charset="-122"/>
+                <a:cs typeface="Cambria" pitchFamily="34" charset="-120"/>
+              </a:rPr>
+              <a:t>Grounded RAG chatbot</a:t>
+            </a:r>
+            <a:endParaRPr lang="en-US" sz="1450" dirty="0"/>
+          </a:p>
+        </p:txBody>
+      </p:sp>
+      <p:sp>
+        <p:nvSpPr>
+          <p:cNvPr id="10" name="Text 8"/>
+          <p:cNvSpPr txBox="1"/>
+          <p:nvPr/>
+        </p:nvSpPr>
+        <p:spPr>
+          <a:xfrm>
+            <a:off x="6446520" y="1709928"/>
+            <a:ext cx="4526280" cy="594360"/>
+          </a:xfrm>
+          <a:prstGeom prst="rect">
+            <a:avLst/>
+          </a:prstGeom>
+          <a:noFill/>
+          <a:ln/>
+        </p:spPr>
+        <p:txBody>
+          <a:bodyPr wrap="square" rtlCol="0" anchor="ctr"/>
+          <a:lstStyle/>
+          <a:p>
+            <a:pPr indent="0" marL="0">
+              <a:lnSpc>
+                <a:spcPts val="1400"/>
+              </a:lnSpc>
+              <a:buNone/>
+            </a:pPr>
+            <a:r>
+              <a:rPr lang="en-US" sz="1150" dirty="0">
+                <a:solidFill>
+                  <a:srgbClr val="6B7280"/>
+                </a:solidFill>
+                <a:latin typeface="Calibri" pitchFamily="34" charset="0"/>
+                <a:ea typeface="Calibri" pitchFamily="34" charset="-122"/>
+                <a:cs typeface="Calibri" pitchFamily="34" charset="-120"/>
+              </a:rPr>
+              <a:t>TF-IDF retrieval over 6 news sources + real citations via Semantic Scholar/arXiv</a:t>
+            </a:r>
+            <a:endParaRPr lang="en-US" sz="1150" dirty="0"/>
+          </a:p>
+        </p:txBody>
+      </p:sp>
+      <p:sp>
+        <p:nvSpPr>
+          <p:cNvPr id="11" name="Shape 9"/>
+          <p:cNvSpPr/>
+          <p:nvPr/>
+        </p:nvSpPr>
+        <p:spPr>
+          <a:xfrm>
+            <a:off x="548640" y="2587752"/>
+            <a:ext cx="384048" cy="384048"/>
+          </a:xfrm>
+          <a:prstGeom prst="ellipse">
+            <a:avLst/>
+          </a:prstGeom>
+          <a:solidFill>
+            <a:srgbClr val="E7EEFB"/>
+          </a:solidFill>
+          <a:ln/>
+        </p:spPr>
+        <p:txBody>
+          <a:bodyPr/>
+          <a:p/>
+        </p:txBody>
+      </p:sp>
+      <p:sp>
+        <p:nvSpPr>
+          <p:cNvPr id="12" name="Text 10"/>
+          <p:cNvSpPr txBox="1"/>
+          <p:nvPr/>
+        </p:nvSpPr>
+        <p:spPr>
+          <a:xfrm>
+            <a:off x="548640" y="2587752"/>
+            <a:ext cx="384048" cy="384048"/>
+          </a:xfrm>
+          <a:prstGeom prst="rect">
+            <a:avLst/>
+          </a:prstGeom>
+          <a:noFill/>
+          <a:ln/>
+        </p:spPr>
+        <p:txBody>
+          <a:bodyPr wrap="square" rtlCol="0" anchor="ctr"/>
+          <a:lstStyle/>
+          <a:p>
+            <a:pPr algn="ctr" indent="0" marL="0">
+              <a:buNone/>
+            </a:pPr>
+            <a:r>
+              <a:rPr lang="en-US" sz="1600" b="1" dirty="0">
+                <a:solidFill>
+                  <a:srgbClr val="1E2761"/>
+                </a:solidFill>
+                <a:latin typeface="Cambria" pitchFamily="34" charset="0"/>
+                <a:ea typeface="Cambria" pitchFamily="34" charset="-122"/>
+                <a:cs typeface="Cambria" pitchFamily="34" charset="-120"/>
+              </a:rPr>
+              <a:t>✓</a:t>
+            </a:r>
+            <a:endParaRPr lang="en-US" sz="1600" dirty="0"/>
+          </a:p>
+        </p:txBody>
+      </p:sp>
+      <p:sp>
+        <p:nvSpPr>
+          <p:cNvPr id="13" name="Text 11"/>
+          <p:cNvSpPr txBox="1"/>
+          <p:nvPr/>
+        </p:nvSpPr>
+        <p:spPr>
+          <a:xfrm>
+            <a:off x="1097280" y="2496312"/>
+            <a:ext cx="4526280" cy="320040"/>
+          </a:xfrm>
+          <a:prstGeom prst="rect">
+            <a:avLst/>
+          </a:prstGeom>
+          <a:noFill/>
+          <a:ln/>
+        </p:spPr>
+        <p:txBody>
+          <a:bodyPr wrap="square" rtlCol="0" anchor="ctr"/>
+          <a:lstStyle/>
+          <a:p>
+            <a:pPr indent="0" marL="0">
+              <a:buNone/>
+            </a:pPr>
+            <a:r>
+              <a:rPr lang="en-US" sz="1450" b="1" dirty="0">
+                <a:solidFill>
+                  <a:srgbClr val="1A1A2E"/>
+                </a:solidFill>
+                <a:latin typeface="Cambria" pitchFamily="34" charset="0"/>
+                <a:ea typeface="Cambria" pitchFamily="34" charset="-122"/>
+                <a:cs typeface="Cambria" pitchFamily="34" charset="-120"/>
+              </a:rPr>
+              <a:t>5-tier market-data fallback</a:t>
+            </a:r>
+            <a:endParaRPr lang="en-US" sz="1450" dirty="0"/>
+          </a:p>
+        </p:txBody>
+      </p:sp>
+      <p:sp>
+        <p:nvSpPr>
+          <p:cNvPr id="14" name="Text 12"/>
+          <p:cNvSpPr txBox="1"/>
+          <p:nvPr/>
+        </p:nvSpPr>
+        <p:spPr>
+          <a:xfrm>
+            <a:off x="1097280" y="2807208"/>
+            <a:ext cx="4526280" cy="594360"/>
+          </a:xfrm>
+          <a:prstGeom prst="rect">
+            <a:avLst/>
+          </a:prstGeom>
+          <a:noFill/>
+          <a:ln/>
+        </p:spPr>
+        <p:txBody>
+          <a:bodyPr wrap="square" rtlCol="0" anchor="ctr"/>
+          <a:lstStyle/>
+          <a:p>
+            <a:pPr indent="0" marL="0">
+              <a:lnSpc>
+                <a:spcPts val="1400"/>
+              </a:lnSpc>
+              <a:buNone/>
+            </a:pPr>
+            <a:r>
+              <a:rPr lang="en-US" sz="1150" dirty="0">
+                <a:solidFill>
+                  <a:srgbClr val="6B7280"/>
+                </a:solidFill>
+                <a:latin typeface="Calibri" pitchFamily="34" charset="0"/>
+                <a:ea typeface="Calibri" pitchFamily="34" charset="-122"/>
+                <a:cs typeface="Calibri" pitchFamily="34" charset="-120"/>
+              </a:rPr>
+              <a:t>yfinance → Yahoo direct → Tiingo → Twelve Data → Alpha Vantage</a:t>
+            </a:r>
+            <a:endParaRPr lang="en-US" sz="1150" dirty="0"/>
+          </a:p>
+        </p:txBody>
+      </p:sp>
+      <p:sp>
+        <p:nvSpPr>
+          <p:cNvPr id="15" name="Shape 13"/>
+          <p:cNvSpPr/>
+          <p:nvPr/>
+        </p:nvSpPr>
+        <p:spPr>
+          <a:xfrm>
+            <a:off x="5897880" y="2587752"/>
+            <a:ext cx="384048" cy="384048"/>
+          </a:xfrm>
+          <a:prstGeom prst="ellipse">
+            <a:avLst/>
+          </a:prstGeom>
+          <a:solidFill>
+            <a:srgbClr val="E7EEFB"/>
+          </a:solidFill>
+          <a:ln/>
+        </p:spPr>
+        <p:txBody>
+          <a:bodyPr/>
+          <a:p/>
+        </p:txBody>
+      </p:sp>
+      <p:sp>
+        <p:nvSpPr>
+          <p:cNvPr id="16" name="Text 14"/>
+          <p:cNvSpPr txBox="1"/>
+          <p:nvPr/>
+        </p:nvSpPr>
+        <p:spPr>
+          <a:xfrm>
+            <a:off x="5897880" y="2587752"/>
+            <a:ext cx="384048" cy="384048"/>
+          </a:xfrm>
+          <a:prstGeom prst="rect">
+            <a:avLst/>
+          </a:prstGeom>
+          <a:noFill/>
+          <a:ln/>
+        </p:spPr>
+        <p:txBody>
+          <a:bodyPr wrap="square" rtlCol="0" anchor="ctr"/>
+          <a:lstStyle/>
+          <a:p>
+            <a:pPr algn="ctr" indent="0" marL="0">
+              <a:buNone/>
+            </a:pPr>
+            <a:r>
+              <a:rPr lang="en-US" sz="1600" b="1" dirty="0">
+                <a:solidFill>
+                  <a:srgbClr val="1E2761"/>
+                </a:solidFill>
+                <a:latin typeface="Cambria" pitchFamily="34" charset="0"/>
+                <a:ea typeface="Cambria" pitchFamily="34" charset="-122"/>
+                <a:cs typeface="Cambria" pitchFamily="34" charset="-120"/>
+              </a:rPr>
+              <a:t>✓</a:t>
+            </a:r>
+            <a:endParaRPr lang="en-US" sz="1600" dirty="0"/>
+          </a:p>
+        </p:txBody>
+      </p:sp>
+      <p:sp>
+        <p:nvSpPr>
+          <p:cNvPr id="17" name="Text 15"/>
+          <p:cNvSpPr txBox="1"/>
+          <p:nvPr/>
+        </p:nvSpPr>
+        <p:spPr>
+          <a:xfrm>
+            <a:off x="6446520" y="2496312"/>
+            <a:ext cx="4526280" cy="320040"/>
+          </a:xfrm>
+          <a:prstGeom prst="rect">
+            <a:avLst/>
+          </a:prstGeom>
+          <a:noFill/>
+          <a:ln/>
+        </p:spPr>
+        <p:txBody>
+          <a:bodyPr wrap="square" rtlCol="0" anchor="ctr"/>
+          <a:lstStyle/>
+          <a:p>
+            <a:pPr indent="0" marL="0">
+              <a:buNone/>
+            </a:pPr>
+            <a:r>
+              <a:rPr lang="en-US" sz="1450" b="1" dirty="0">
+                <a:solidFill>
+                  <a:srgbClr val="1A1A2E"/>
+                </a:solidFill>
+                <a:latin typeface="Cambria" pitchFamily="34" charset="0"/>
+                <a:ea typeface="Cambria" pitchFamily="34" charset="-122"/>
+                <a:cs typeface="Cambria" pitchFamily="34" charset="-120"/>
+              </a:rPr>
+              <a:t>5-tier LLM fallback</a:t>
+            </a:r>
+            <a:endParaRPr lang="en-US" sz="1450" dirty="0"/>
+          </a:p>
+        </p:txBody>
+      </p:sp>
+      <p:sp>
+        <p:nvSpPr>
+          <p:cNvPr id="18" name="Text 16"/>
+          <p:cNvSpPr txBox="1"/>
+          <p:nvPr/>
+        </p:nvSpPr>
+        <p:spPr>
+          <a:xfrm>
+            <a:off x="6446520" y="2807208"/>
+            <a:ext cx="4526280" cy="594360"/>
+          </a:xfrm>
+          <a:prstGeom prst="rect">
+            <a:avLst/>
+          </a:prstGeom>
+          <a:noFill/>
+          <a:ln/>
+        </p:spPr>
+        <p:txBody>
+          <a:bodyPr wrap="square" rtlCol="0" anchor="ctr"/>
+          <a:lstStyle/>
+          <a:p>
+            <a:pPr indent="0" marL="0">
+              <a:lnSpc>
+                <a:spcPts val="1400"/>
+              </a:lnSpc>
+              <a:buNone/>
+            </a:pPr>
+            <a:r>
+              <a:rPr lang="en-US" sz="1150" dirty="0">
+                <a:solidFill>
+                  <a:srgbClr val="6B7280"/>
+                </a:solidFill>
+                <a:latin typeface="Calibri" pitchFamily="34" charset="0"/>
+                <a:ea typeface="Calibri" pitchFamily="34" charset="-122"/>
+                <a:cs typeface="Calibri" pitchFamily="34" charset="-120"/>
+              </a:rPr>
+              <a:t>Groq → OpenRouter → Cerebras → SambaNova → local Ollama</a:t>
+            </a:r>
+            <a:endParaRPr lang="en-US" sz="1150" dirty="0"/>
+          </a:p>
+        </p:txBody>
+      </p:sp>
+      <p:sp>
+        <p:nvSpPr>
+          <p:cNvPr id="19" name="Shape 17"/>
+          <p:cNvSpPr/>
+          <p:nvPr/>
+        </p:nvSpPr>
+        <p:spPr>
+          <a:xfrm>
+            <a:off x="548640" y="3685032"/>
+            <a:ext cx="384048" cy="384048"/>
+          </a:xfrm>
+          <a:prstGeom prst="ellipse">
+            <a:avLst/>
+          </a:prstGeom>
+          <a:solidFill>
+            <a:srgbClr val="E7EEFB"/>
+          </a:solidFill>
+          <a:ln/>
+        </p:spPr>
+        <p:txBody>
+          <a:bodyPr/>
+          <a:p/>
+        </p:txBody>
+      </p:sp>
+      <p:sp>
+        <p:nvSpPr>
+          <p:cNvPr id="20" name="Text 18"/>
+          <p:cNvSpPr txBox="1"/>
+          <p:nvPr/>
+        </p:nvSpPr>
+        <p:spPr>
+          <a:xfrm>
+            <a:off x="548640" y="3685032"/>
+            <a:ext cx="384048" cy="384048"/>
+          </a:xfrm>
+          <a:prstGeom prst="rect">
+            <a:avLst/>
+          </a:prstGeom>
+          <a:noFill/>
+          <a:ln/>
+        </p:spPr>
+        <p:txBody>
+          <a:bodyPr wrap="square" rtlCol="0" anchor="ctr"/>
+          <a:lstStyle/>
+          <a:p>
+            <a:pPr algn="ctr" indent="0" marL="0">
+              <a:buNone/>
+            </a:pPr>
+            <a:r>
+              <a:rPr lang="en-US" sz="1600" b="1" dirty="0">
+                <a:solidFill>
+                  <a:srgbClr val="1E2761"/>
+                </a:solidFill>
+                <a:latin typeface="Cambria" pitchFamily="34" charset="0"/>
+                <a:ea typeface="Cambria" pitchFamily="34" charset="-122"/>
+                <a:cs typeface="Cambria" pitchFamily="34" charset="-120"/>
+              </a:rPr>
+              <a:t>✓</a:t>
+            </a:r>
+            <a:endParaRPr lang="en-US" sz="1600" dirty="0"/>
+          </a:p>
+        </p:txBody>
+      </p:sp>
+      <p:sp>
+        <p:nvSpPr>
+          <p:cNvPr id="21" name="Text 19"/>
+          <p:cNvSpPr txBox="1"/>
+          <p:nvPr/>
+        </p:nvSpPr>
+        <p:spPr>
+          <a:xfrm>
+            <a:off x="1097280" y="3593592"/>
+            <a:ext cx="4526280" cy="320040"/>
+          </a:xfrm>
+          <a:prstGeom prst="rect">
+            <a:avLst/>
+          </a:prstGeom>
+          <a:noFill/>
+          <a:ln/>
+        </p:spPr>
+        <p:txBody>
+          <a:bodyPr wrap="square" rtlCol="0" anchor="ctr"/>
+          <a:lstStyle/>
+          <a:p>
+            <a:pPr indent="0" marL="0">
+              <a:buNone/>
+            </a:pPr>
+            <a:r>
+              <a:rPr lang="en-US" sz="1450" b="1" dirty="0">
+                <a:solidFill>
+                  <a:srgbClr val="1A1A2E"/>
+                </a:solidFill>
+                <a:latin typeface="Cambria" pitchFamily="34" charset="0"/>
+                <a:ea typeface="Cambria" pitchFamily="34" charset="-122"/>
+                <a:cs typeface="Cambria" pitchFamily="34" charset="-120"/>
+              </a:rPr>
+              <a:t>6 forecast models</a:t>
+            </a:r>
+            <a:endParaRPr lang="en-US" sz="1450" dirty="0"/>
+          </a:p>
+        </p:txBody>
+      </p:sp>
+      <p:sp>
+        <p:nvSpPr>
+          <p:cNvPr id="22" name="Text 20"/>
+          <p:cNvSpPr txBox="1"/>
+          <p:nvPr/>
+        </p:nvSpPr>
+        <p:spPr>
+          <a:xfrm>
+            <a:off x="1097280" y="3904488"/>
+            <a:ext cx="4526280" cy="594360"/>
+          </a:xfrm>
+          <a:prstGeom prst="rect">
+            <a:avLst/>
+          </a:prstGeom>
+          <a:noFill/>
+          <a:ln/>
+        </p:spPr>
+        <p:txBody>
+          <a:bodyPr wrap="square" rtlCol="0" anchor="ctr"/>
+          <a:lstStyle/>
+          <a:p>
+            <a:pPr indent="0" marL="0">
+              <a:lnSpc>
+                <a:spcPts val="1400"/>
+              </a:lnSpc>
+              <a:buNone/>
+            </a:pPr>
+            <a:r>
+              <a:rPr lang="en-US" sz="1150" dirty="0">
+                <a:solidFill>
+                  <a:srgbClr val="6B7280"/>
+                </a:solidFill>
+                <a:latin typeface="Calibri" pitchFamily="34" charset="0"/>
+                <a:ea typeface="Calibri" pitchFamily="34" charset="-122"/>
+                <a:cs typeface="Calibri" pitchFamily="34" charset="-120"/>
+              </a:rPr>
+              <a:t>Naive, ETS, Theta, ARIMA, ML regression, LSTM — same shape, swappable</a:t>
+            </a:r>
+            <a:endParaRPr lang="en-US" sz="1150" dirty="0"/>
+          </a:p>
+        </p:txBody>
+      </p:sp>
+      <p:sp>
+        <p:nvSpPr>
+          <p:cNvPr id="23" name="Shape 21"/>
+          <p:cNvSpPr/>
+          <p:nvPr/>
+        </p:nvSpPr>
+        <p:spPr>
+          <a:xfrm>
+            <a:off x="5897880" y="3685032"/>
+            <a:ext cx="384048" cy="384048"/>
+          </a:xfrm>
+          <a:prstGeom prst="ellipse">
+            <a:avLst/>
+          </a:prstGeom>
+          <a:solidFill>
+            <a:srgbClr val="E7EEFB"/>
+          </a:solidFill>
+          <a:ln/>
+        </p:spPr>
+        <p:txBody>
+          <a:bodyPr/>
+          <a:p/>
+        </p:txBody>
+      </p:sp>
+      <p:sp>
+        <p:nvSpPr>
+          <p:cNvPr id="24" name="Text 22"/>
+          <p:cNvSpPr txBox="1"/>
+          <p:nvPr/>
+        </p:nvSpPr>
+        <p:spPr>
+          <a:xfrm>
+            <a:off x="5897880" y="3685032"/>
+            <a:ext cx="384048" cy="384048"/>
+          </a:xfrm>
+          <a:prstGeom prst="rect">
+            <a:avLst/>
+          </a:prstGeom>
+          <a:noFill/>
+          <a:ln/>
+        </p:spPr>
+        <p:txBody>
+          <a:bodyPr wrap="square" rtlCol="0" anchor="ctr"/>
+          <a:lstStyle/>
+          <a:p>
+            <a:pPr algn="ctr" indent="0" marL="0">
+              <a:buNone/>
+            </a:pPr>
+            <a:r>
+              <a:rPr lang="en-US" sz="1600" b="1" dirty="0">
+                <a:solidFill>
+                  <a:srgbClr val="1E2761"/>
+                </a:solidFill>
+                <a:latin typeface="Cambria" pitchFamily="34" charset="0"/>
+                <a:ea typeface="Cambria" pitchFamily="34" charset="-122"/>
+                <a:cs typeface="Cambria" pitchFamily="34" charset="-120"/>
+              </a:rPr>
+              <a:t>✓</a:t>
+            </a:r>
+            <a:endParaRPr lang="en-US" sz="1600" dirty="0"/>
+          </a:p>
+        </p:txBody>
+      </p:sp>
+      <p:sp>
+        <p:nvSpPr>
+          <p:cNvPr id="25" name="Text 23"/>
+          <p:cNvSpPr txBox="1"/>
+          <p:nvPr/>
+        </p:nvSpPr>
+        <p:spPr>
+          <a:xfrm>
+            <a:off x="6446520" y="3593592"/>
+            <a:ext cx="4526280" cy="320040"/>
+          </a:xfrm>
+          <a:prstGeom prst="rect">
+            <a:avLst/>
+          </a:prstGeom>
+          <a:noFill/>
+          <a:ln/>
+        </p:spPr>
+        <p:txBody>
+          <a:bodyPr wrap="square" rtlCol="0" anchor="ctr"/>
+          <a:lstStyle/>
+          <a:p>
+            <a:pPr indent="0" marL="0">
+              <a:buNone/>
+            </a:pPr>
+            <a:r>
+              <a:rPr lang="en-US" sz="1450" b="1" dirty="0">
+                <a:solidFill>
+                  <a:srgbClr val="1A1A2E"/>
+                </a:solidFill>
+                <a:latin typeface="Cambria" pitchFamily="34" charset="0"/>
+                <a:ea typeface="Cambria" pitchFamily="34" charset="-122"/>
+                <a:cs typeface="Cambria" pitchFamily="34" charset="-120"/>
+              </a:rPr>
+              <a:t>Fundamentals &amp; factor exposure</a:t>
+            </a:r>
+            <a:endParaRPr lang="en-US" sz="1450" dirty="0"/>
+          </a:p>
+        </p:txBody>
+      </p:sp>
+      <p:sp>
+        <p:nvSpPr>
+          <p:cNvPr id="26" name="Text 24"/>
+          <p:cNvSpPr txBox="1"/>
+          <p:nvPr/>
+        </p:nvSpPr>
+        <p:spPr>
+          <a:xfrm>
+            <a:off x="6446520" y="3904488"/>
+            <a:ext cx="4526280" cy="594360"/>
+          </a:xfrm>
+          <a:prstGeom prst="rect">
+            <a:avLst/>
+          </a:prstGeom>
+          <a:noFill/>
+          <a:ln/>
+        </p:spPr>
+        <p:txBody>
+          <a:bodyPr wrap="square" rtlCol="0" anchor="ctr"/>
+          <a:lstStyle/>
+          <a:p>
+            <a:pPr indent="0" marL="0">
+              <a:lnSpc>
+                <a:spcPts val="1400"/>
+              </a:lnSpc>
+              <a:buNone/>
+            </a:pPr>
+            <a:r>
+              <a:rPr lang="en-US" sz="1150" dirty="0">
+                <a:solidFill>
+                  <a:srgbClr val="6B7280"/>
+                </a:solidFill>
+                <a:latin typeface="Calibri" pitchFamily="34" charset="0"/>
+                <a:ea typeface="Calibri" pitchFamily="34" charset="-122"/>
+                <a:cs typeface="Calibri" pitchFamily="34" charset="-120"/>
+              </a:rPr>
+              <a:t>Fama-French 3/5-factor loadings, P/E, beta, dividend yield per ticker</a:t>
+            </a:r>
+            <a:endParaRPr lang="en-US" sz="1150" dirty="0"/>
+          </a:p>
+        </p:txBody>
+      </p:sp>
+      <p:sp>
+        <p:nvSpPr>
+          <p:cNvPr id="27" name="Text 25"/>
+          <p:cNvSpPr txBox="1"/>
+          <p:nvPr/>
+        </p:nvSpPr>
+        <p:spPr>
+          <a:xfrm>
+            <a:off x="457200" y="6492240"/>
+            <a:ext cx="11247120" cy="274320"/>
+          </a:xfrm>
+          <a:prstGeom prst="rect">
+            <a:avLst/>
+          </a:prstGeom>
+          <a:noFill/>
+          <a:ln/>
+        </p:spPr>
+        <p:txBody>
+          <a:bodyPr wrap="square" rtlCol="0" anchor="ctr"/>
+          <a:lstStyle/>
+          <a:p>
+            <a:pPr algn="l" indent="0" marL="0">
+              <a:buNone/>
+            </a:pPr>
+            <a:r>
+              <a:rPr lang="en-US" sz="1000" dirty="0">
+                <a:solidFill>
+                  <a:srgbClr val="6B7280"/>
+                </a:solidFill>
+                <a:latin typeface="Calibri" pitchFamily="34" charset="0"/>
+                <a:ea typeface="Calibri" pitchFamily="34" charset="-122"/>
+                <a:cs typeface="Calibri" pitchFamily="34" charset="-120"/>
+              </a:rPr>
+              <a:t>Every external call fails soft — no single API key or provider outage ever crashes the app</a:t>
+            </a:r>
+            <a:endParaRPr lang="en-US" sz="1000" dirty="0"/>
+          </a:p>
+        </p:txBody>
+      </p:sp>
+    </p:spTree>
+  </p:cSld>
+  <p:clrMapOvr>
+    <a:masterClrMapping/>
+  </p:clrMapOvr>
+</p:sld>
+</file>
+
 <file path=ppt/slides/slide2.xml><?xml version="1.0" encoding="utf-8"?>
 <p:sld xmlns:a="http://schemas.openxmlformats.org/drawingml/2006/main" xmlns:r="http://schemas.openxmlformats.org/officeDocument/2006/relationships" xmlns:p="http://schemas.openxmlformats.org/presentationml/2006/main">
   <p:cSld name="Slide 2">
@@ -2859,7 +3834,7 @@
                 <a:ea typeface="Calibri" pitchFamily="34" charset="-122"/>
                 <a:cs typeface="Calibri" pitchFamily="34" charset="-120"/>
               </a:rPr>
-              <a:t>Naive / ETS / ARIMA, GARCH(1,1) volatility</a:t>
+              <a:t>Naive / ETS / Theta / ARIMA / ML regression / LSTM, GARCH(1,1) volatility</a:t>
             </a:r>
             <a:endParaRPr lang="en-US" sz="1250" dirty="0"/>
           </a:p>
@@ -3454,7 +4429,7 @@
                 <a:ea typeface="Cambria" pitchFamily="34" charset="-122"/>
                 <a:cs typeface="Cambria" pitchFamily="34" charset="-120"/>
               </a:rPr>
-              <a:t>47.0%</a:t>
+              <a:t>55.8%</a:t>
             </a:r>
             <a:endParaRPr lang="en-US" sz="4000" dirty="0"/>
           </a:p>
@@ -3558,7 +4533,7 @@
                 <a:ea typeface="Cambria" pitchFamily="34" charset="-122"/>
                 <a:cs typeface="Cambria" pitchFamily="34" charset="-120"/>
               </a:rPr>
-              <a:t>21.6%</a:t>
+              <a:t>30.5%</a:t>
             </a:r>
             <a:endParaRPr lang="en-US" sz="4000" dirty="0"/>
           </a:p>
@@ -3662,7 +4637,7 @@
                 <a:ea typeface="Cambria" pitchFamily="34" charset="-122"/>
                 <a:cs typeface="Cambria" pitchFamily="34" charset="-120"/>
               </a:rPr>
-              <a:t>1.99</a:t>
+              <a:t>1.70</a:t>
             </a:r>
             <a:endParaRPr lang="en-US" sz="4000" dirty="0"/>
           </a:p>
@@ -3766,7 +4741,7 @@
                 <a:ea typeface="Cambria" pitchFamily="34" charset="-122"/>
                 <a:cs typeface="Cambria" pitchFamily="34" charset="-120"/>
               </a:rPr>
-              <a:t>3.64</a:t>
+              <a:t>3.37</a:t>
             </a:r>
             <a:endParaRPr lang="en-US" sz="4000" dirty="0"/>
           </a:p>
@@ -3847,7 +4822,7 @@
                 <a:ea typeface="Calibri" pitchFamily="34" charset="-122"/>
                 <a:cs typeface="Calibri" pitchFamily="34" charset="-120"/>
               </a:rPr>
-              <a:t>Optimal weights lean into AI-related growth (NVDA, AVGO) balanced by defensive staples (WMT, XOM, JPM) — with short positions elsewhere under the short-selling toggle.</a:t>
+              <a:t>Optimal weights lean into AI-related growth (NVDA, AVGO, PANW, MSFT) at the 25% cap, offset by short positions in ADBE and QCOM under the short-selling toggle.</a:t>
             </a:r>
             <a:endParaRPr lang="en-US" sz="1350" dirty="0"/>
           </a:p>
@@ -4390,7 +5365,7 @@
                           <a:ea typeface="Calibri" pitchFamily="34" charset="-122"/>
                           <a:cs typeface="Calibri" pitchFamily="34" charset="-120"/>
                         </a:rPr>
-                        <a:t>0.77</a:t>
+                        <a:t>-0.59</a:t>
                       </a:r>
                       <a:endParaRPr lang="en-US" sz="1350" dirty="0">
                         <a:latin typeface="Calibri" charset="0"/>
@@ -4458,7 +5433,7 @@
                           <a:ea typeface="Calibri" pitchFamily="34" charset="-122"/>
                           <a:cs typeface="Calibri" pitchFamily="34" charset="-120"/>
                         </a:rPr>
-                        <a:t>1.13</a:t>
+                        <a:t>2.95</a:t>
                       </a:r>
                       <a:endParaRPr lang="en-US" sz="1350" dirty="0">
                         <a:latin typeface="Calibri" charset="0"/>
@@ -4526,7 +5501,7 @@
                           <a:ea typeface="Calibri" pitchFamily="34" charset="-122"/>
                           <a:cs typeface="Calibri" pitchFamily="34" charset="-120"/>
                         </a:rPr>
-                        <a:t>29%</a:t>
+                        <a:t>-24.4%</a:t>
                       </a:r>
                       <a:endParaRPr lang="en-US" sz="1350" dirty="0">
                         <a:latin typeface="Calibri" charset="0"/>
@@ -4664,7 +5639,7 @@
                           <a:ea typeface="Calibri" pitchFamily="34" charset="-122"/>
                           <a:cs typeface="Calibri" pitchFamily="34" charset="-120"/>
                         </a:rPr>
-                        <a:t>0.86</a:t>
+                        <a:t>0.23</a:t>
                       </a:r>
                       <a:endParaRPr lang="en-US" sz="1350" dirty="0">
                         <a:latin typeface="Calibri" charset="0"/>
@@ -4732,7 +5707,7 @@
                           <a:ea typeface="Calibri" pitchFamily="34" charset="-122"/>
                           <a:cs typeface="Calibri" pitchFamily="34" charset="-120"/>
                         </a:rPr>
-                        <a:t>1.56</a:t>
+                        <a:t>2.95</a:t>
                       </a:r>
                       <a:endParaRPr lang="en-US" sz="1350" dirty="0">
                         <a:latin typeface="Calibri" charset="0"/>
@@ -4800,7 +5775,7 @@
                           <a:ea typeface="Calibri" pitchFamily="34" charset="-122"/>
                           <a:cs typeface="Calibri" pitchFamily="34" charset="-120"/>
                         </a:rPr>
-                        <a:t>14%</a:t>
+                        <a:t>6.1%</a:t>
                       </a:r>
                       <a:endParaRPr lang="en-US" sz="1350" dirty="0">
                         <a:latin typeface="Calibri" charset="0"/>
@@ -4938,7 +5913,7 @@
                           <a:ea typeface="Calibri" pitchFamily="34" charset="-122"/>
                           <a:cs typeface="Calibri" pitchFamily="34" charset="-120"/>
                         </a:rPr>
-                        <a:t>5.13</a:t>
+                        <a:t>8.89</a:t>
                       </a:r>
                       <a:endParaRPr lang="en-US" sz="1350" dirty="0">
                         <a:latin typeface="Calibri" charset="0"/>
@@ -5006,7 +5981,7 @@
                           <a:ea typeface="Calibri" pitchFamily="34" charset="-122"/>
                           <a:cs typeface="Calibri" pitchFamily="34" charset="-120"/>
                         </a:rPr>
-                        <a:t>1.73</a:t>
+                        <a:t>3.17</a:t>
                       </a:r>
                       <a:endParaRPr lang="en-US" sz="1350" dirty="0">
                         <a:latin typeface="Calibri" charset="0"/>
@@ -5074,7 +6049,7 @@
                           <a:ea typeface="Calibri" pitchFamily="34" charset="-122"/>
                           <a:cs typeface="Calibri" pitchFamily="34" charset="-120"/>
                         </a:rPr>
-                        <a:t>290%</a:t>
+                        <a:t>2844.7%</a:t>
                       </a:r>
                       <a:endParaRPr lang="en-US" sz="1350" dirty="0">
                         <a:latin typeface="Calibri" charset="0"/>
@@ -5166,7 +6141,7 @@
                 <a:ea typeface="Calibri" pitchFamily="34" charset="-122"/>
                 <a:cs typeface="Calibri" pitchFamily="34" charset="-120"/>
               </a:rPr>
-              <a:t>Forecast-based beat Historical-based on Sharpe in 4 of 6 windows (67%) — a real, if modest, edge. Realized-optimal is hindsight-perfect and only a benchmark, never achievable live.</a:t>
+              <a:t>Forecast-based beat Historical-based on Sharpe in 83% of the 6 windows tested — a real, if modest, edge. Realized-optimal is hindsight-perfect and only a benchmark, never achievable live.</a:t>
             </a:r>
             <a:endParaRPr lang="en-US" sz="1350" dirty="0"/>
           </a:p>
@@ -6247,7 +7222,7 @@
                 <a:ea typeface="Calibri" pitchFamily="34" charset="-122"/>
                 <a:cs typeface="Calibri" pitchFamily="34" charset="-120"/>
               </a:rPr>
-              <a:t>314 tests passing · mypy --strict clean and blocking in CI</a:t>
+              <a:t>300+ tests passing · mypy --strict clean and blocking in CI</a:t>
             </a:r>
             <a:endParaRPr lang="en-US" sz="1000" dirty="0"/>
           </a:p>

</xml_diff>